<commit_message>
feat(frota): atualiza lista oficial de frotas Betim (Fleet 1 e 2), status e previsoes de saida da manutencao
- Purga dados e usuarios ficticios preparando o sistema para operacao real
- Atualiza catalogo da filial Betim com 272 ativos (245 PTA e 27 Guindastes/Outros) extraidos de fleet 1.xls e fleet 2.xls
- Mapeia 138 ativos em manutencao com data de liberacao, dias restantes e data de movimentacao do PCM
- Exibe alertas de prazo de saida nos cards de frota e adiciona colunas no exportador CSV
- Adiciona modal de carga de dados operacionais e importacao de usuarios por perfil
- Regenera apresentacao corporativa Sistema de Inspecao & Qualidade de Frota.pptx
</commit_message>
<xml_diff>
--- a/Sistema de Inspeção & Qualidade de Frota.pptx
+++ b/Sistema de Inspeção & Qualidade de Frota.pptx
@@ -16,6 +16,7 @@
     <p:sldId id="264" r:id="rId15"/>
     <p:sldId id="265" r:id="rId16"/>
     <p:sldId id="266" r:id="rId17"/>
+    <p:sldId id="267" r:id="rId18"/>
   </p:sldIdLst>
   <p:sldSz cx="12191695" cy="6858000" type="screen4x3"/>
   <p:notesSz cx="6858000" cy="9144000"/>
@@ -4547,7 +4548,7 @@
               </a:defRPr>
             </a:pPr>
             <a:r>
-              <a:t>GANHOS TÉCNICOS, OPERACIONAIS E JURÍDICOS PARA A LOCAR</a:t>
+              <a:t>TRANSIÇÃO DA FASE DE TESTES PARA OPERAÇÃO REAL • PURGA DE DADOS E CARGA CORPORATIVA</a:t>
             </a:r>
           </a:p>
           <a:p>
@@ -4563,7 +4564,567 @@
               </a:defRPr>
             </a:pPr>
             <a:r>
-              <a:t>10. Conclusão &amp; Benefícios Estratégicos</a:t>
+              <a:t>10. Entrada em Operação &amp; Carga de Dados Oficiais</a:t>
+            </a:r>
+          </a:p>
+        </p:txBody>
+      </p:sp>
+      <p:pic>
+        <p:nvPicPr>
+          <p:cNvPr id="5" name="Picture 4" descr="locar_logo_transparent.png"/>
+          <p:cNvPicPr>
+            <a:picLocks noChangeAspect="1"/>
+          </p:cNvPicPr>
+          <p:nvPr/>
+        </p:nvPicPr>
+        <p:blipFill>
+          <a:blip r:embed="rId2"/>
+          <a:stretch>
+            <a:fillRect/>
+          </a:stretch>
+        </p:blipFill>
+        <p:spPr>
+          <a:xfrm>
+            <a:off x="9875520" y="274320"/>
+            <a:ext cx="1645920" cy="660994"/>
+          </a:xfrm>
+          <a:prstGeom prst="rect">
+            <a:avLst/>
+          </a:prstGeom>
+        </p:spPr>
+      </p:pic>
+      <p:sp>
+        <p:nvSpPr>
+          <p:cNvPr id="6" name="Rounded Rectangle 5"/>
+          <p:cNvSpPr/>
+          <p:nvPr/>
+        </p:nvSpPr>
+        <p:spPr>
+          <a:xfrm>
+            <a:off x="731520" y="1645920"/>
+            <a:ext cx="5212080" cy="2011680"/>
+          </a:xfrm>
+          <a:prstGeom prst="roundRect">
+            <a:avLst/>
+          </a:prstGeom>
+          <a:solidFill>
+            <a:srgbClr val="2E2B2B"/>
+          </a:solidFill>
+          <a:ln w="15240">
+            <a:solidFill>
+              <a:srgbClr val="5C5656"/>
+            </a:solidFill>
+          </a:ln>
+        </p:spPr>
+        <p:style>
+          <a:lnRef idx="1">
+            <a:schemeClr val="accent1"/>
+          </a:lnRef>
+          <a:fillRef idx="3">
+            <a:schemeClr val="accent1"/>
+          </a:fillRef>
+          <a:effectRef idx="2">
+            <a:schemeClr val="accent1"/>
+          </a:effectRef>
+          <a:fontRef idx="minor">
+            <a:schemeClr val="lt1"/>
+          </a:fontRef>
+        </p:style>
+        <p:txBody>
+          <a:bodyPr rtlCol="0" anchor="ctr"/>
+          <a:lstStyle/>
+          <a:p>
+            <a:pPr algn="ctr"/>
+          </a:p>
+        </p:txBody>
+      </p:sp>
+      <p:sp>
+        <p:nvSpPr>
+          <p:cNvPr id="7" name="TextBox 6"/>
+          <p:cNvSpPr txBox="1"/>
+          <p:nvPr/>
+        </p:nvSpPr>
+        <p:spPr>
+          <a:xfrm>
+            <a:off x="1005840" y="1874520"/>
+            <a:ext cx="4663440" cy="1554480"/>
+          </a:xfrm>
+          <a:prstGeom prst="rect">
+            <a:avLst/>
+          </a:prstGeom>
+          <a:noFill/>
+        </p:spPr>
+        <p:txBody>
+          <a:bodyPr wrap="square">
+            <a:spAutoFit/>
+          </a:bodyPr>
+          <a:lstStyle/>
+          <a:p>
+            <a:pPr>
+              <a:defRPr sz="1600" b="1">
+                <a:solidFill>
+                  <a:srgbClr val="FFF212"/>
+                </a:solidFill>
+              </a:defRPr>
+            </a:pPr>
+            <a:r>
+              <a:t>🧹  Purga Rigorosa de Testes</a:t>
+            </a:r>
+          </a:p>
+          <a:p>
+            <a:pPr>
+              <a:spcBef>
+                <a:spcPts val="800"/>
+              </a:spcBef>
+              <a:defRPr sz="1200">
+                <a:solidFill>
+                  <a:srgbClr val="F1F5F9"/>
+                </a:solidFill>
+              </a:defRPr>
+            </a:pPr>
+            <a:r>
+              <a:t>Remoção integral de todos os laudos simulados, vistorias preliminares, solicitações fictícias do PCM e usuários de homologação. Elimina contaminação de dados.</a:t>
+            </a:r>
+          </a:p>
+        </p:txBody>
+      </p:sp>
+      <p:sp>
+        <p:nvSpPr>
+          <p:cNvPr id="8" name="Rounded Rectangle 7"/>
+          <p:cNvSpPr/>
+          <p:nvPr/>
+        </p:nvSpPr>
+        <p:spPr>
+          <a:xfrm>
+            <a:off x="6217920" y="1645920"/>
+            <a:ext cx="5212080" cy="2011680"/>
+          </a:xfrm>
+          <a:prstGeom prst="roundRect">
+            <a:avLst/>
+          </a:prstGeom>
+          <a:solidFill>
+            <a:srgbClr val="2E2B2B"/>
+          </a:solidFill>
+          <a:ln w="15240">
+            <a:solidFill>
+              <a:srgbClr val="5C5656"/>
+            </a:solidFill>
+          </a:ln>
+        </p:spPr>
+        <p:style>
+          <a:lnRef idx="1">
+            <a:schemeClr val="accent1"/>
+          </a:lnRef>
+          <a:fillRef idx="3">
+            <a:schemeClr val="accent1"/>
+          </a:fillRef>
+          <a:effectRef idx="2">
+            <a:schemeClr val="accent1"/>
+          </a:effectRef>
+          <a:fontRef idx="minor">
+            <a:schemeClr val="lt1"/>
+          </a:fontRef>
+        </p:style>
+        <p:txBody>
+          <a:bodyPr rtlCol="0" anchor="ctr"/>
+          <a:lstStyle/>
+          <a:p>
+            <a:pPr algn="ctr"/>
+          </a:p>
+        </p:txBody>
+      </p:sp>
+      <p:sp>
+        <p:nvSpPr>
+          <p:cNvPr id="9" name="TextBox 8"/>
+          <p:cNvSpPr txBox="1"/>
+          <p:nvPr/>
+        </p:nvSpPr>
+        <p:spPr>
+          <a:xfrm>
+            <a:off x="6492240" y="1874520"/>
+            <a:ext cx="4663440" cy="1554480"/>
+          </a:xfrm>
+          <a:prstGeom prst="rect">
+            <a:avLst/>
+          </a:prstGeom>
+          <a:noFill/>
+        </p:spPr>
+        <p:txBody>
+          <a:bodyPr wrap="square">
+            <a:spAutoFit/>
+          </a:bodyPr>
+          <a:lstStyle/>
+          <a:p>
+            <a:pPr>
+              <a:defRPr sz="1600" b="1">
+                <a:solidFill>
+                  <a:srgbClr val="FFF212"/>
+                </a:solidFill>
+              </a:defRPr>
+            </a:pPr>
+            <a:r>
+              <a:t>👥  Carga Oficial de Usuários (RBAC)</a:t>
+            </a:r>
+          </a:p>
+          <a:p>
+            <a:pPr>
+              <a:spcBef>
+                <a:spcPts val="800"/>
+              </a:spcBef>
+              <a:defRPr sz="1200">
+                <a:solidFill>
+                  <a:srgbClr val="F1F5F9"/>
+                </a:solidFill>
+              </a:defRPr>
+            </a:pPr>
+            <a:r>
+              <a:t>Importador em lote de colaboradores com atribuição estrita de papéis: Inspetor de Campo, Gestor PCM, Gestão de Frota, Comercial e Administrador QSMS com hashes SHA-256.</a:t>
+            </a:r>
+          </a:p>
+        </p:txBody>
+      </p:sp>
+      <p:sp>
+        <p:nvSpPr>
+          <p:cNvPr id="10" name="Rounded Rectangle 9"/>
+          <p:cNvSpPr/>
+          <p:nvPr/>
+        </p:nvSpPr>
+        <p:spPr>
+          <a:xfrm>
+            <a:off x="731520" y="3931920"/>
+            <a:ext cx="5212080" cy="2011680"/>
+          </a:xfrm>
+          <a:prstGeom prst="roundRect">
+            <a:avLst/>
+          </a:prstGeom>
+          <a:solidFill>
+            <a:srgbClr val="2E2B2B"/>
+          </a:solidFill>
+          <a:ln w="15240">
+            <a:solidFill>
+              <a:srgbClr val="5C5656"/>
+            </a:solidFill>
+          </a:ln>
+        </p:spPr>
+        <p:style>
+          <a:lnRef idx="1">
+            <a:schemeClr val="accent1"/>
+          </a:lnRef>
+          <a:fillRef idx="3">
+            <a:schemeClr val="accent1"/>
+          </a:fillRef>
+          <a:effectRef idx="2">
+            <a:schemeClr val="accent1"/>
+          </a:effectRef>
+          <a:fontRef idx="minor">
+            <a:schemeClr val="lt1"/>
+          </a:fontRef>
+        </p:style>
+        <p:txBody>
+          <a:bodyPr rtlCol="0" anchor="ctr"/>
+          <a:lstStyle/>
+          <a:p>
+            <a:pPr algn="ctr"/>
+          </a:p>
+        </p:txBody>
+      </p:sp>
+      <p:sp>
+        <p:nvSpPr>
+          <p:cNvPr id="11" name="TextBox 10"/>
+          <p:cNvSpPr txBox="1"/>
+          <p:nvPr/>
+        </p:nvSpPr>
+        <p:spPr>
+          <a:xfrm>
+            <a:off x="1005840" y="4160520"/>
+            <a:ext cx="4663440" cy="1554480"/>
+          </a:xfrm>
+          <a:prstGeom prst="rect">
+            <a:avLst/>
+          </a:prstGeom>
+          <a:noFill/>
+        </p:spPr>
+        <p:txBody>
+          <a:bodyPr wrap="square">
+            <a:spAutoFit/>
+          </a:bodyPr>
+          <a:lstStyle/>
+          <a:p>
+            <a:pPr>
+              <a:defRPr sz="1600" b="1">
+                <a:solidFill>
+                  <a:srgbClr val="FFF212"/>
+                </a:solidFill>
+              </a:defRPr>
+            </a:pPr>
+            <a:r>
+              <a:t>🚜  Atualização de Status da Frota</a:t>
+            </a:r>
+          </a:p>
+          <a:p>
+            <a:pPr>
+              <a:spcBef>
+                <a:spcPts val="800"/>
+              </a:spcBef>
+              <a:defRPr sz="1200">
+                <a:solidFill>
+                  <a:srgbClr val="F1F5F9"/>
+                </a:solidFill>
+              </a:defRPr>
+            </a:pPr>
+            <a:r>
+              <a:t>Atualização em lote do status real de operação dos 272 ativos da base Betim: 138 em manutenção (com prazos exatos de saída do PCM), 98 locadas, 33 disponíveis e 3 reservadas.</a:t>
+            </a:r>
+          </a:p>
+        </p:txBody>
+      </p:sp>
+      <p:sp>
+        <p:nvSpPr>
+          <p:cNvPr id="12" name="Rounded Rectangle 11"/>
+          <p:cNvSpPr/>
+          <p:nvPr/>
+        </p:nvSpPr>
+        <p:spPr>
+          <a:xfrm>
+            <a:off x="6217920" y="3931920"/>
+            <a:ext cx="5212080" cy="2011680"/>
+          </a:xfrm>
+          <a:prstGeom prst="roundRect">
+            <a:avLst/>
+          </a:prstGeom>
+          <a:solidFill>
+            <a:srgbClr val="2E2B2B"/>
+          </a:solidFill>
+          <a:ln w="15240">
+            <a:solidFill>
+              <a:srgbClr val="5C5656"/>
+            </a:solidFill>
+          </a:ln>
+        </p:spPr>
+        <p:style>
+          <a:lnRef idx="1">
+            <a:schemeClr val="accent1"/>
+          </a:lnRef>
+          <a:fillRef idx="3">
+            <a:schemeClr val="accent1"/>
+          </a:fillRef>
+          <a:effectRef idx="2">
+            <a:schemeClr val="accent1"/>
+          </a:effectRef>
+          <a:fontRef idx="minor">
+            <a:schemeClr val="lt1"/>
+          </a:fontRef>
+        </p:style>
+        <p:txBody>
+          <a:bodyPr rtlCol="0" anchor="ctr"/>
+          <a:lstStyle/>
+          <a:p>
+            <a:pPr algn="ctr"/>
+          </a:p>
+        </p:txBody>
+      </p:sp>
+      <p:sp>
+        <p:nvSpPr>
+          <p:cNvPr id="13" name="TextBox 12"/>
+          <p:cNvSpPr txBox="1"/>
+          <p:nvPr/>
+        </p:nvSpPr>
+        <p:spPr>
+          <a:xfrm>
+            <a:off x="6492240" y="4160520"/>
+            <a:ext cx="4663440" cy="1554480"/>
+          </a:xfrm>
+          <a:prstGeom prst="rect">
+            <a:avLst/>
+          </a:prstGeom>
+          <a:noFill/>
+        </p:spPr>
+        <p:txBody>
+          <a:bodyPr wrap="square">
+            <a:spAutoFit/>
+          </a:bodyPr>
+          <a:lstStyle/>
+          <a:p>
+            <a:pPr>
+              <a:defRPr sz="1600" b="1">
+                <a:solidFill>
+                  <a:srgbClr val="FFF212"/>
+                </a:solidFill>
+              </a:defRPr>
+            </a:pPr>
+            <a:r>
+              <a:t>🔒  Governança &amp; Custódia Pericial Pura</a:t>
+            </a:r>
+          </a:p>
+          <a:p>
+            <a:pPr>
+              <a:spcBef>
+                <a:spcPts val="800"/>
+              </a:spcBef>
+              <a:defRPr sz="1200">
+                <a:solidFill>
+                  <a:srgbClr val="F1F5F9"/>
+                </a:solidFill>
+              </a:defRPr>
+            </a:pPr>
+            <a:r>
+              <a:t>O sistema inicia a operação com custódia limpa. Cada checklist assinado no pátio passa a ser registro técnico oficial, inalterável e pronto para auditorias externas.</a:t>
+            </a:r>
+          </a:p>
+        </p:txBody>
+      </p:sp>
+    </p:spTree>
+  </p:cSld>
+  <p:clrMapOvr>
+    <a:masterClrMapping/>
+  </p:clrMapOvr>
+</p:sld>
+</file>
+
+<file path=ppt/slides/slide12.xml><?xml version="1.0" encoding="utf-8"?>
+<p:sld xmlns:a="http://schemas.openxmlformats.org/drawingml/2006/main" xmlns:p="http://schemas.openxmlformats.org/presentationml/2006/main" xmlns:r="http://schemas.openxmlformats.org/officeDocument/2006/relationships">
+  <p:cSld>
+    <p:spTree>
+      <p:nvGrpSpPr>
+        <p:cNvPr id="1" name=""/>
+        <p:cNvGrpSpPr/>
+        <p:nvPr/>
+      </p:nvGrpSpPr>
+      <p:grpSpPr/>
+      <p:sp>
+        <p:nvSpPr>
+          <p:cNvPr id="2" name="Rectangle 1"/>
+          <p:cNvSpPr/>
+          <p:nvPr/>
+        </p:nvSpPr>
+        <p:spPr>
+          <a:xfrm>
+            <a:off x="0" y="0"/>
+            <a:ext cx="12191695" cy="6858000"/>
+          </a:xfrm>
+          <a:prstGeom prst="rect">
+            <a:avLst/>
+          </a:prstGeom>
+          <a:solidFill>
+            <a:srgbClr val="383535"/>
+          </a:solidFill>
+          <a:ln>
+            <a:noFill/>
+          </a:ln>
+        </p:spPr>
+        <p:style>
+          <a:lnRef idx="1">
+            <a:schemeClr val="accent1"/>
+          </a:lnRef>
+          <a:fillRef idx="3">
+            <a:schemeClr val="accent1"/>
+          </a:fillRef>
+          <a:effectRef idx="2">
+            <a:schemeClr val="accent1"/>
+          </a:effectRef>
+          <a:fontRef idx="minor">
+            <a:schemeClr val="lt1"/>
+          </a:fontRef>
+        </p:style>
+        <p:txBody>
+          <a:bodyPr rtlCol="0" anchor="ctr"/>
+          <a:lstStyle/>
+          <a:p>
+            <a:pPr algn="ctr"/>
+          </a:p>
+        </p:txBody>
+      </p:sp>
+      <p:sp>
+        <p:nvSpPr>
+          <p:cNvPr id="3" name="Rectangle 2"/>
+          <p:cNvSpPr/>
+          <p:nvPr/>
+        </p:nvSpPr>
+        <p:spPr>
+          <a:xfrm>
+            <a:off x="0" y="0"/>
+            <a:ext cx="12191695" cy="91440"/>
+          </a:xfrm>
+          <a:prstGeom prst="rect">
+            <a:avLst/>
+          </a:prstGeom>
+          <a:solidFill>
+            <a:srgbClr val="FFF212"/>
+          </a:solidFill>
+          <a:ln>
+            <a:noFill/>
+          </a:ln>
+        </p:spPr>
+        <p:style>
+          <a:lnRef idx="1">
+            <a:schemeClr val="accent1"/>
+          </a:lnRef>
+          <a:fillRef idx="3">
+            <a:schemeClr val="accent1"/>
+          </a:fillRef>
+          <a:effectRef idx="2">
+            <a:schemeClr val="accent1"/>
+          </a:effectRef>
+          <a:fontRef idx="minor">
+            <a:schemeClr val="lt1"/>
+          </a:fontRef>
+        </p:style>
+        <p:txBody>
+          <a:bodyPr rtlCol="0" anchor="ctr"/>
+          <a:lstStyle/>
+          <a:p>
+            <a:pPr algn="ctr"/>
+          </a:p>
+        </p:txBody>
+      </p:sp>
+      <p:sp>
+        <p:nvSpPr>
+          <p:cNvPr id="4" name="TextBox 3"/>
+          <p:cNvSpPr txBox="1"/>
+          <p:nvPr/>
+        </p:nvSpPr>
+        <p:spPr>
+          <a:xfrm>
+            <a:off x="731520" y="292608"/>
+            <a:ext cx="8686800" cy="1005840"/>
+          </a:xfrm>
+          <a:prstGeom prst="rect">
+            <a:avLst/>
+          </a:prstGeom>
+          <a:noFill/>
+        </p:spPr>
+        <p:txBody>
+          <a:bodyPr wrap="square" lIns="0" tIns="0" rIns="0" bIns="0">
+            <a:spAutoFit/>
+          </a:bodyPr>
+          <a:lstStyle/>
+          <a:p>
+            <a:pPr>
+              <a:defRPr sz="950" b="1">
+                <a:solidFill>
+                  <a:srgbClr val="FFF212"/>
+                </a:solidFill>
+                <a:latin typeface="Arial"/>
+              </a:defRPr>
+            </a:pPr>
+            <a:r>
+              <a:t>GANHOS TÉCNICOS, OPERACIONAIS E JURÍDICOS PARA A LOCAR</a:t>
+            </a:r>
+          </a:p>
+          <a:p>
+            <a:pPr>
+              <a:spcBef>
+                <a:spcPts val="300"/>
+              </a:spcBef>
+              <a:defRPr sz="2200" b="1">
+                <a:solidFill>
+                  <a:srgbClr val="FFFFFF"/>
+                </a:solidFill>
+                <a:latin typeface="Arial"/>
+              </a:defRPr>
+            </a:pPr>
+            <a:r>
+              <a:t>11. Conclusão &amp; Benefícios Estratégicos</a:t>
             </a:r>
           </a:p>
         </p:txBody>
@@ -5266,7 +5827,7 @@
               </a:defRPr>
             </a:pPr>
             <a:r>
-              <a:t>KPIs em tempo real e grid dos 273 ativos de Betim.</a:t>
+              <a:t>KPIs em tempo real e grid dos 272 ativos de Betim.</a:t>
             </a:r>
           </a:p>
         </p:txBody>
@@ -7308,51 +7869,63 @@
           <a:p>
             <a:pPr>
               <a:spcBef>
-                <a:spcPts val="1000"/>
+                <a:spcPts val="800"/>
               </a:spcBef>
-              <a:defRPr sz="1150">
+              <a:defRPr sz="1100">
                 <a:solidFill>
                   <a:srgbClr val="F1F5F9"/>
                 </a:solidFill>
               </a:defRPr>
             </a:pPr>
             <a:r>
-              <a:t>• 273 Ativos Cadastrados:</a:t>
+              <a:t>• 272 Ativos Cadastrados (Bases Fleet 1 &amp; 2):</a:t>
             </a:r>
             <a:br/>
             <a:r>
-              <a:t>  - Divisão PTA: 245 plataformas elevatórias (Genie, JLG, Haulotte).</a:t>
+              <a:t>  - Divisão PTA: 245 plataformas elevatórias (Genie, JLG, Haulotte, Skyjack).</a:t>
             </a:r>
             <a:br/>
             <a:r>
-              <a:t>  - Divisão Guindastes: 29 ativos (Liebherr, Grove, Muncks, Empilhadeiras).</a:t>
+              <a:t>  - Divisão Guindastes &amp; Outros: 27 ativos (Liebherr, Grove, Muncks, Empilhadeiras).</a:t>
             </a:r>
             <a:br/>
             <a:br/>
             <a:r>
-              <a:t>• Filtros Instantâneos de Status:</a:t>
+              <a:t>• Status Operacionais Oficiais da Filial Betim:</a:t>
             </a:r>
             <a:br/>
             <a:r>
-              <a:t>  Disponíveis, Reservadas, Locadas e Em Manutenção.</a:t>
+              <a:t>  - 138 em Manutenção (com prazos exatos de saída e dias p/ liberar do PCM).</a:t>
+            </a:r>
+            <a:br/>
+            <a:r>
+              <a:t>  - 98 Locadas em operação em clientes vigentes.</a:t>
+            </a:r>
+            <a:br/>
+            <a:r>
+              <a:t>  - 33 Disponíveis no pátio aptas para mobilização imediata.</a:t>
+            </a:r>
+            <a:br/>
+            <a:r>
+              <a:t>  - 3 Reservadas comerciais em negociação.</a:t>
             </a:r>
             <a:br/>
             <a:br/>
             <a:r>
-              <a:t>• Alerta de Manutenção Preventiva:</a:t>
+              <a:t>• Controle de Prazos de Saída da Manutenção:</a:t>
             </a:r>
             <a:br/>
             <a:r>
-              <a:t>  Identifica automaticamente horímetros próximos do ciclo de 250h/500h com badge de preventiva.</a:t>
+              <a:t>  Data de liberação e contagem regressiva visíveis em cada card e exportação CSV.</a:t>
             </a:r>
             <a:br/>
             <a:br/>
             <a:r>
-              <a:t>• Exportação de Relatórios CSV:</a:t>
+              <a:t>• Alerta de Manutenção Preventiva:</a:t>
             </a:r>
             <a:br/>
             <a:r>
-              <a:t>  Planilhas formatadas para gestão e auditoria gerencial.</a:t>
+              <a:t>  Identifica automaticamente horímetros próximos do ciclo de 250h/500h com badge de preventiva.</a:t>
             </a:r>
           </a:p>
         </p:txBody>

</xml_diff>

<commit_message>
feat(auth): define Maikon Pinho como Administrador Soberano exclusivo e blinda governanca
- Cria o usuario mestre maikon.pinho (maikon.pinho@locar.com.br) com senha com hash SHA-256
- Estabelece a regra estrita de Administrador Unico: qualquer outro usuario com perfil admin e automaticamente rebaixado para gestor
- Exige autorizacao soberana para operacoes administrativas: mudanca de bases fora dos fluxos, cadastro/zeragem de usuarios, alteracao de senhas e perfis
- Atualiza apresentacao corporativa Sistema de Inspecao & Qualidade de Frota.pptx documentando o pilar de governanca
</commit_message>
<xml_diff>
--- a/Sistema de Inspeção & Qualidade de Frota.pptx
+++ b/Sistema de Inspeção & Qualidade de Frota.pptx
@@ -4763,7 +4763,7 @@
               </a:defRPr>
             </a:pPr>
             <a:r>
-              <a:t>👥  Carga Oficial de Usuários (RBAC)</a:t>
+              <a:t>👥  Governança &amp; Administrador Único (RBAC)</a:t>
             </a:r>
           </a:p>
           <a:p>
@@ -4778,7 +4778,7 @@
               </a:defRPr>
             </a:pPr>
             <a:r>
-              <a:t>Importador em lote de colaboradores com atribuição estrita de papéis: Inspetor de Campo, Gestor PCM, Gestão de Frota, Comercial e Administrador QSMS com hashes SHA-256.</a:t>
+              <a:t>Perfil 'admin' exclusivo e restrito ao gestor Maikon Pinho (maikon.pinho@locar.com.br). Somente o administrador soberano pode alterar bases de dados, criar usuários, redefinir senhas e atribuir perfis.</a:t>
             </a:r>
           </a:p>
         </p:txBody>

</xml_diff>

<commit_message>
feat(auth): adiciona suporte a cadastro e login de usuarios via CPF ou e-mail
</commit_message>
<xml_diff>
--- a/Sistema de Inspeção & Qualidade de Frota.pptx
+++ b/Sistema de Inspeção & Qualidade de Frota.pptx
@@ -4763,7 +4763,7 @@
               </a:defRPr>
             </a:pPr>
             <a:r>
-              <a:t>👥  Governança &amp; Administrador Único (RBAC)</a:t>
+              <a:t>👥  Governança &amp; Cadastro por CPF / E-mail (RBAC)</a:t>
             </a:r>
           </a:p>
           <a:p>
@@ -4778,7 +4778,7 @@
               </a:defRPr>
             </a:pPr>
             <a:r>
-              <a:t>Perfil 'admin' exclusivo e restrito ao gestor Maikon Pinho (maikon.pinho@locar.com.br). Somente o administrador soberano pode alterar bases de dados, criar usuários, redefinir senhas e atribuir perfis.</a:t>
+              <a:t>Perfil 'admin' exclusivo do gestor Maikon Pinho (maikon.pinho@locar.com.br). Cadastro oficial de operadores habilitado por CPF ou E-mail corporativo, com PIN com hash SHA-256 e controle soberano de permissões.</a:t>
             </a:r>
           </a:p>
         </p:txBody>

</xml_diff>

<commit_message>
feat(ai): adiciona balao flutuante e chat de perguntas e respostas com IA no canto inferior esquerdo
</commit_message>
<xml_diff>
--- a/Sistema de Inspeção & Qualidade de Frota.pptx
+++ b/Sistema de Inspeção & Qualidade de Frota.pptx
@@ -4953,7 +4953,7 @@
               </a:defRPr>
             </a:pPr>
             <a:r>
-              <a:t>🔒  Governança &amp; Custódia Pericial Pura</a:t>
+              <a:t>🤖  IA Copilot &amp; Suporte Inteligente (Q&amp;A)</a:t>
             </a:r>
           </a:p>
           <a:p>
@@ -4968,7 +4968,7 @@
               </a:defRPr>
             </a:pPr>
             <a:r>
-              <a:t>O sistema inicia a operação com custódia limpa. Cada checklist assinado no pátio passa a ser registro técnico oficial, inalterável e pronto para auditorias externas.</a:t>
+              <a:t>Balão flutuante interativo no canto inferior esquerdo com chat inteligente: tira dúvidas em tempo real sobre vistorias, NRs 11/12/18, cadastro por CPF/e-mail, fluxo do PCM e regras do sistema.</a:t>
             </a:r>
           </a:p>
         </p:txBody>

</xml_diff>

<commit_message>
feat: adiciona canal de informativos de falhas e sugestoes ao administrador e otimizacoes responsivas mobile/desktop
</commit_message>
<xml_diff>
--- a/Sistema de Inspeção & Qualidade de Frota.pptx
+++ b/Sistema de Inspeção & Qualidade de Frota.pptx
@@ -17,6 +17,7 @@
     <p:sldId id="265" r:id="rId16"/>
     <p:sldId id="266" r:id="rId17"/>
     <p:sldId id="267" r:id="rId18"/>
+    <p:sldId id="268" r:id="rId19"/>
   </p:sldIdLst>
   <p:sldSz cx="12191695" cy="6858000" type="screen4x3"/>
   <p:notesSz cx="6858000" cy="9144000"/>
@@ -4953,7 +4954,7 @@
               </a:defRPr>
             </a:pPr>
             <a:r>
-              <a:t>🤖  IA Copilot &amp; Suporte Inteligente (Q&amp;A)</a:t>
+              <a:t>📢  Informativo de Falhas &amp; Sugestões (E-mail Direto)</a:t>
             </a:r>
           </a:p>
           <a:p>
@@ -4968,7 +4969,7 @@
               </a:defRPr>
             </a:pPr>
             <a:r>
-              <a:t>Balão flutuante interativo no canto inferior direito com chat inteligente: tira dúvidas em tempo real sobre vistorias, NRs 11/12/18, cadastro por CPF/e-mail, fluxo do PCM e regras do sistema.</a:t>
+              <a:t>Canal no cabeçalho e rodapé para relato de bugs e sugestões de melhoria. Cada chamado gera protocolo único e é despachado por e-mail formal para maikon.pinho@locar.com.br com inbox de gestão no painel.</a:t>
             </a:r>
           </a:p>
         </p:txBody>
@@ -5108,7 +5109,7 @@
               </a:defRPr>
             </a:pPr>
             <a:r>
-              <a:t>GANHOS TÉCNICOS, OPERACIONAIS E JURÍDICOS PARA A LOCAR</a:t>
+              <a:t>AUTO-ADAPTAÇÃO ERGONÔMICA PARA DESKTOP NO ESCRITÓRIO E SMARTPHONES NO PÁTIO</a:t>
             </a:r>
           </a:p>
           <a:p>
@@ -5124,7 +5125,567 @@
               </a:defRPr>
             </a:pPr>
             <a:r>
-              <a:t>11. Conclusão &amp; Benefícios Estratégicos</a:t>
+              <a:t>11. Otimização Responsiva: Computador &amp; Mobile (PWA)</a:t>
+            </a:r>
+          </a:p>
+        </p:txBody>
+      </p:sp>
+      <p:pic>
+        <p:nvPicPr>
+          <p:cNvPr id="5" name="Picture 4" descr="locar_logo_transparent.png"/>
+          <p:cNvPicPr>
+            <a:picLocks noChangeAspect="1"/>
+          </p:cNvPicPr>
+          <p:nvPr/>
+        </p:nvPicPr>
+        <p:blipFill>
+          <a:blip r:embed="rId2"/>
+          <a:stretch>
+            <a:fillRect/>
+          </a:stretch>
+        </p:blipFill>
+        <p:spPr>
+          <a:xfrm>
+            <a:off x="9875520" y="274320"/>
+            <a:ext cx="1645920" cy="660994"/>
+          </a:xfrm>
+          <a:prstGeom prst="rect">
+            <a:avLst/>
+          </a:prstGeom>
+        </p:spPr>
+      </p:pic>
+      <p:sp>
+        <p:nvSpPr>
+          <p:cNvPr id="6" name="Rounded Rectangle 5"/>
+          <p:cNvSpPr/>
+          <p:nvPr/>
+        </p:nvSpPr>
+        <p:spPr>
+          <a:xfrm>
+            <a:off x="731520" y="1645920"/>
+            <a:ext cx="5212080" cy="2011680"/>
+          </a:xfrm>
+          <a:prstGeom prst="roundRect">
+            <a:avLst/>
+          </a:prstGeom>
+          <a:solidFill>
+            <a:srgbClr val="2E2B2B"/>
+          </a:solidFill>
+          <a:ln w="15240">
+            <a:solidFill>
+              <a:srgbClr val="5C5656"/>
+            </a:solidFill>
+          </a:ln>
+        </p:spPr>
+        <p:style>
+          <a:lnRef idx="1">
+            <a:schemeClr val="accent1"/>
+          </a:lnRef>
+          <a:fillRef idx="3">
+            <a:schemeClr val="accent1"/>
+          </a:fillRef>
+          <a:effectRef idx="2">
+            <a:schemeClr val="accent1"/>
+          </a:effectRef>
+          <a:fontRef idx="minor">
+            <a:schemeClr val="lt1"/>
+          </a:fontRef>
+        </p:style>
+        <p:txBody>
+          <a:bodyPr rtlCol="0" anchor="ctr"/>
+          <a:lstStyle/>
+          <a:p>
+            <a:pPr algn="ctr"/>
+          </a:p>
+        </p:txBody>
+      </p:sp>
+      <p:sp>
+        <p:nvSpPr>
+          <p:cNvPr id="7" name="TextBox 6"/>
+          <p:cNvSpPr txBox="1"/>
+          <p:nvPr/>
+        </p:nvSpPr>
+        <p:spPr>
+          <a:xfrm>
+            <a:off x="1005840" y="1874520"/>
+            <a:ext cx="4663440" cy="1554480"/>
+          </a:xfrm>
+          <a:prstGeom prst="rect">
+            <a:avLst/>
+          </a:prstGeom>
+          <a:noFill/>
+        </p:spPr>
+        <p:txBody>
+          <a:bodyPr wrap="square">
+            <a:spAutoFit/>
+          </a:bodyPr>
+          <a:lstStyle/>
+          <a:p>
+            <a:pPr>
+              <a:defRPr sz="1600" b="1">
+                <a:solidFill>
+                  <a:srgbClr val="FFF212"/>
+                </a:solidFill>
+              </a:defRPr>
+            </a:pPr>
+            <a:r>
+              <a:t>💻  Visão Computador &amp; Escritório (Desktop)</a:t>
+            </a:r>
+          </a:p>
+          <a:p>
+            <a:pPr>
+              <a:spcBef>
+                <a:spcPts val="800"/>
+              </a:spcBef>
+              <a:defRPr sz="1200">
+                <a:solidFill>
+                  <a:srgbClr val="F1F5F9"/>
+                </a:solidFill>
+              </a:defRPr>
+            </a:pPr>
+            <a:r>
+              <a:t>Visão analítica ampla com grids em múltiplas colunas (1440px), painel de KPIs executivos com status por divisão (PTA / Guindastes), visualização ampla de laudos e atalhos de gestão.</a:t>
+            </a:r>
+          </a:p>
+        </p:txBody>
+      </p:sp>
+      <p:sp>
+        <p:nvSpPr>
+          <p:cNvPr id="8" name="Rounded Rectangle 7"/>
+          <p:cNvSpPr/>
+          <p:nvPr/>
+        </p:nvSpPr>
+        <p:spPr>
+          <a:xfrm>
+            <a:off x="6217920" y="1645920"/>
+            <a:ext cx="5212080" cy="2011680"/>
+          </a:xfrm>
+          <a:prstGeom prst="roundRect">
+            <a:avLst/>
+          </a:prstGeom>
+          <a:solidFill>
+            <a:srgbClr val="2E2B2B"/>
+          </a:solidFill>
+          <a:ln w="15240">
+            <a:solidFill>
+              <a:srgbClr val="5C5656"/>
+            </a:solidFill>
+          </a:ln>
+        </p:spPr>
+        <p:style>
+          <a:lnRef idx="1">
+            <a:schemeClr val="accent1"/>
+          </a:lnRef>
+          <a:fillRef idx="3">
+            <a:schemeClr val="accent1"/>
+          </a:fillRef>
+          <a:effectRef idx="2">
+            <a:schemeClr val="accent1"/>
+          </a:effectRef>
+          <a:fontRef idx="minor">
+            <a:schemeClr val="lt1"/>
+          </a:fontRef>
+        </p:style>
+        <p:txBody>
+          <a:bodyPr rtlCol="0" anchor="ctr"/>
+          <a:lstStyle/>
+          <a:p>
+            <a:pPr algn="ctr"/>
+          </a:p>
+        </p:txBody>
+      </p:sp>
+      <p:sp>
+        <p:nvSpPr>
+          <p:cNvPr id="9" name="TextBox 8"/>
+          <p:cNvSpPr txBox="1"/>
+          <p:nvPr/>
+        </p:nvSpPr>
+        <p:spPr>
+          <a:xfrm>
+            <a:off x="6492240" y="1874520"/>
+            <a:ext cx="4663440" cy="1554480"/>
+          </a:xfrm>
+          <a:prstGeom prst="rect">
+            <a:avLst/>
+          </a:prstGeom>
+          <a:noFill/>
+        </p:spPr>
+        <p:txBody>
+          <a:bodyPr wrap="square">
+            <a:spAutoFit/>
+          </a:bodyPr>
+          <a:lstStyle/>
+          <a:p>
+            <a:pPr>
+              <a:defRPr sz="1600" b="1">
+                <a:solidFill>
+                  <a:srgbClr val="FFF212"/>
+                </a:solidFill>
+              </a:defRPr>
+            </a:pPr>
+            <a:r>
+              <a:t>📱  Visão Celular &amp; Tablet no Pátio (Mobile)</a:t>
+            </a:r>
+          </a:p>
+          <a:p>
+            <a:pPr>
+              <a:spcBef>
+                <a:spcPts val="800"/>
+              </a:spcBef>
+              <a:defRPr sz="1200">
+                <a:solidFill>
+                  <a:srgbClr val="F1F5F9"/>
+                </a:solidFill>
+              </a:defRPr>
+            </a:pPr>
+            <a:r>
+              <a:t>Adaptação automática para smartphones (Android e iOS): layout em coluna única, botões e touch-targets de fácil acionamento com o polegar (&gt;=44px) e abas de rolagem tátil suave.</a:t>
+            </a:r>
+          </a:p>
+        </p:txBody>
+      </p:sp>
+      <p:sp>
+        <p:nvSpPr>
+          <p:cNvPr id="10" name="Rounded Rectangle 9"/>
+          <p:cNvSpPr/>
+          <p:nvPr/>
+        </p:nvSpPr>
+        <p:spPr>
+          <a:xfrm>
+            <a:off x="731520" y="3931920"/>
+            <a:ext cx="5212080" cy="2011680"/>
+          </a:xfrm>
+          <a:prstGeom prst="roundRect">
+            <a:avLst/>
+          </a:prstGeom>
+          <a:solidFill>
+            <a:srgbClr val="2E2B2B"/>
+          </a:solidFill>
+          <a:ln w="15240">
+            <a:solidFill>
+              <a:srgbClr val="5C5656"/>
+            </a:solidFill>
+          </a:ln>
+        </p:spPr>
+        <p:style>
+          <a:lnRef idx="1">
+            <a:schemeClr val="accent1"/>
+          </a:lnRef>
+          <a:fillRef idx="3">
+            <a:schemeClr val="accent1"/>
+          </a:fillRef>
+          <a:effectRef idx="2">
+            <a:schemeClr val="accent1"/>
+          </a:effectRef>
+          <a:fontRef idx="minor">
+            <a:schemeClr val="lt1"/>
+          </a:fontRef>
+        </p:style>
+        <p:txBody>
+          <a:bodyPr rtlCol="0" anchor="ctr"/>
+          <a:lstStyle/>
+          <a:p>
+            <a:pPr algn="ctr"/>
+          </a:p>
+        </p:txBody>
+      </p:sp>
+      <p:sp>
+        <p:nvSpPr>
+          <p:cNvPr id="11" name="TextBox 10"/>
+          <p:cNvSpPr txBox="1"/>
+          <p:nvPr/>
+        </p:nvSpPr>
+        <p:spPr>
+          <a:xfrm>
+            <a:off x="1005840" y="4160520"/>
+            <a:ext cx="4663440" cy="1554480"/>
+          </a:xfrm>
+          <a:prstGeom prst="rect">
+            <a:avLst/>
+          </a:prstGeom>
+          <a:noFill/>
+        </p:spPr>
+        <p:txBody>
+          <a:bodyPr wrap="square">
+            <a:spAutoFit/>
+          </a:bodyPr>
+          <a:lstStyle/>
+          <a:p>
+            <a:pPr>
+              <a:defRPr sz="1600" b="1">
+                <a:solidFill>
+                  <a:srgbClr val="FFF212"/>
+                </a:solidFill>
+              </a:defRPr>
+            </a:pPr>
+            <a:r>
+              <a:t>📷  Câmera e Assinatura Touch em Campo</a:t>
+            </a:r>
+          </a:p>
+          <a:p>
+            <a:pPr>
+              <a:spcBef>
+                <a:spcPts val="800"/>
+              </a:spcBef>
+              <a:defRPr sz="1200">
+                <a:solidFill>
+                  <a:srgbClr val="F1F5F9"/>
+                </a:solidFill>
+              </a:defRPr>
+            </a:pPr>
+            <a:r>
+              <a:t>Acionamento da câmera traseira física do celular (facingMode: environment) para fotos de avarias, além de canvas de assinatura digital por toque com bloqueio de scroll (touch-action: none).</a:t>
+            </a:r>
+          </a:p>
+        </p:txBody>
+      </p:sp>
+      <p:sp>
+        <p:nvSpPr>
+          <p:cNvPr id="12" name="Rounded Rectangle 11"/>
+          <p:cNvSpPr/>
+          <p:nvPr/>
+        </p:nvSpPr>
+        <p:spPr>
+          <a:xfrm>
+            <a:off x="6217920" y="3931920"/>
+            <a:ext cx="5212080" cy="2011680"/>
+          </a:xfrm>
+          <a:prstGeom prst="roundRect">
+            <a:avLst/>
+          </a:prstGeom>
+          <a:solidFill>
+            <a:srgbClr val="2E2B2B"/>
+          </a:solidFill>
+          <a:ln w="15240">
+            <a:solidFill>
+              <a:srgbClr val="5C5656"/>
+            </a:solidFill>
+          </a:ln>
+        </p:spPr>
+        <p:style>
+          <a:lnRef idx="1">
+            <a:schemeClr val="accent1"/>
+          </a:lnRef>
+          <a:fillRef idx="3">
+            <a:schemeClr val="accent1"/>
+          </a:fillRef>
+          <a:effectRef idx="2">
+            <a:schemeClr val="accent1"/>
+          </a:effectRef>
+          <a:fontRef idx="minor">
+            <a:schemeClr val="lt1"/>
+          </a:fontRef>
+        </p:style>
+        <p:txBody>
+          <a:bodyPr rtlCol="0" anchor="ctr"/>
+          <a:lstStyle/>
+          <a:p>
+            <a:pPr algn="ctr"/>
+          </a:p>
+        </p:txBody>
+      </p:sp>
+      <p:sp>
+        <p:nvSpPr>
+          <p:cNvPr id="13" name="TextBox 12"/>
+          <p:cNvSpPr txBox="1"/>
+          <p:nvPr/>
+        </p:nvSpPr>
+        <p:spPr>
+          <a:xfrm>
+            <a:off x="6492240" y="4160520"/>
+            <a:ext cx="4663440" cy="1554480"/>
+          </a:xfrm>
+          <a:prstGeom prst="rect">
+            <a:avLst/>
+          </a:prstGeom>
+          <a:noFill/>
+        </p:spPr>
+        <p:txBody>
+          <a:bodyPr wrap="square">
+            <a:spAutoFit/>
+          </a:bodyPr>
+          <a:lstStyle/>
+          <a:p>
+            <a:pPr>
+              <a:defRPr sz="1600" b="1">
+                <a:solidFill>
+                  <a:srgbClr val="FFF212"/>
+                </a:solidFill>
+              </a:defRPr>
+            </a:pPr>
+            <a:r>
+              <a:t>⚡  PWA Instalável &amp; IA Copilot Flutuante</a:t>
+            </a:r>
+          </a:p>
+          <a:p>
+            <a:pPr>
+              <a:spcBef>
+                <a:spcPts val="800"/>
+              </a:spcBef>
+              <a:defRPr sz="1200">
+                <a:solidFill>
+                  <a:srgbClr val="F1F5F9"/>
+                </a:solidFill>
+              </a:defRPr>
+            </a:pPr>
+            <a:r>
+              <a:t>Pode ser adicionado à tela inicial do celular como App nativo (PWA com Service Worker offline). O balão de IA adapta seu tamanho dinamicamente em qualquer resolução de tela.</a:t>
+            </a:r>
+          </a:p>
+        </p:txBody>
+      </p:sp>
+    </p:spTree>
+  </p:cSld>
+  <p:clrMapOvr>
+    <a:masterClrMapping/>
+  </p:clrMapOvr>
+</p:sld>
+</file>
+
+<file path=ppt/slides/slide13.xml><?xml version="1.0" encoding="utf-8"?>
+<p:sld xmlns:a="http://schemas.openxmlformats.org/drawingml/2006/main" xmlns:p="http://schemas.openxmlformats.org/presentationml/2006/main" xmlns:r="http://schemas.openxmlformats.org/officeDocument/2006/relationships">
+  <p:cSld>
+    <p:spTree>
+      <p:nvGrpSpPr>
+        <p:cNvPr id="1" name=""/>
+        <p:cNvGrpSpPr/>
+        <p:nvPr/>
+      </p:nvGrpSpPr>
+      <p:grpSpPr/>
+      <p:sp>
+        <p:nvSpPr>
+          <p:cNvPr id="2" name="Rectangle 1"/>
+          <p:cNvSpPr/>
+          <p:nvPr/>
+        </p:nvSpPr>
+        <p:spPr>
+          <a:xfrm>
+            <a:off x="0" y="0"/>
+            <a:ext cx="12191695" cy="6858000"/>
+          </a:xfrm>
+          <a:prstGeom prst="rect">
+            <a:avLst/>
+          </a:prstGeom>
+          <a:solidFill>
+            <a:srgbClr val="383535"/>
+          </a:solidFill>
+          <a:ln>
+            <a:noFill/>
+          </a:ln>
+        </p:spPr>
+        <p:style>
+          <a:lnRef idx="1">
+            <a:schemeClr val="accent1"/>
+          </a:lnRef>
+          <a:fillRef idx="3">
+            <a:schemeClr val="accent1"/>
+          </a:fillRef>
+          <a:effectRef idx="2">
+            <a:schemeClr val="accent1"/>
+          </a:effectRef>
+          <a:fontRef idx="minor">
+            <a:schemeClr val="lt1"/>
+          </a:fontRef>
+        </p:style>
+        <p:txBody>
+          <a:bodyPr rtlCol="0" anchor="ctr"/>
+          <a:lstStyle/>
+          <a:p>
+            <a:pPr algn="ctr"/>
+          </a:p>
+        </p:txBody>
+      </p:sp>
+      <p:sp>
+        <p:nvSpPr>
+          <p:cNvPr id="3" name="Rectangle 2"/>
+          <p:cNvSpPr/>
+          <p:nvPr/>
+        </p:nvSpPr>
+        <p:spPr>
+          <a:xfrm>
+            <a:off x="0" y="0"/>
+            <a:ext cx="12191695" cy="91440"/>
+          </a:xfrm>
+          <a:prstGeom prst="rect">
+            <a:avLst/>
+          </a:prstGeom>
+          <a:solidFill>
+            <a:srgbClr val="FFF212"/>
+          </a:solidFill>
+          <a:ln>
+            <a:noFill/>
+          </a:ln>
+        </p:spPr>
+        <p:style>
+          <a:lnRef idx="1">
+            <a:schemeClr val="accent1"/>
+          </a:lnRef>
+          <a:fillRef idx="3">
+            <a:schemeClr val="accent1"/>
+          </a:fillRef>
+          <a:effectRef idx="2">
+            <a:schemeClr val="accent1"/>
+          </a:effectRef>
+          <a:fontRef idx="minor">
+            <a:schemeClr val="lt1"/>
+          </a:fontRef>
+        </p:style>
+        <p:txBody>
+          <a:bodyPr rtlCol="0" anchor="ctr"/>
+          <a:lstStyle/>
+          <a:p>
+            <a:pPr algn="ctr"/>
+          </a:p>
+        </p:txBody>
+      </p:sp>
+      <p:sp>
+        <p:nvSpPr>
+          <p:cNvPr id="4" name="TextBox 3"/>
+          <p:cNvSpPr txBox="1"/>
+          <p:nvPr/>
+        </p:nvSpPr>
+        <p:spPr>
+          <a:xfrm>
+            <a:off x="731520" y="292608"/>
+            <a:ext cx="8686800" cy="1005840"/>
+          </a:xfrm>
+          <a:prstGeom prst="rect">
+            <a:avLst/>
+          </a:prstGeom>
+          <a:noFill/>
+        </p:spPr>
+        <p:txBody>
+          <a:bodyPr wrap="square" lIns="0" tIns="0" rIns="0" bIns="0">
+            <a:spAutoFit/>
+          </a:bodyPr>
+          <a:lstStyle/>
+          <a:p>
+            <a:pPr>
+              <a:defRPr sz="950" b="1">
+                <a:solidFill>
+                  <a:srgbClr val="FFF212"/>
+                </a:solidFill>
+                <a:latin typeface="Arial"/>
+              </a:defRPr>
+            </a:pPr>
+            <a:r>
+              <a:t>GANHOS TÉCNICOS, OPERACIONAIS E JURÍDICOS PARA A LOCAR</a:t>
+            </a:r>
+          </a:p>
+          <a:p>
+            <a:pPr>
+              <a:spcBef>
+                <a:spcPts val="300"/>
+              </a:spcBef>
+              <a:defRPr sz="2200" b="1">
+                <a:solidFill>
+                  <a:srgbClr val="FFFFFF"/>
+                </a:solidFill>
+                <a:latin typeface="Arial"/>
+              </a:defRPr>
+            </a:pPr>
+            <a:r>
+              <a:t>12. Conclusão &amp; Benefícios Estratégicos</a:t>
             </a:r>
           </a:p>
         </p:txBody>

</xml_diff>